<commit_message>
Presentaciones: correccion PSS/F&G y anexos 3D+Gantt
- PSS provision HIMA; F&G detectores AESA + hardware HIMA (ambas presentaciones)
- Nota: instrumentos en skid los instala el vendor, loop checks son alcance AESA
- Presentacion 2: agrega slide 16 (contexto 3D) y slide 17 (Gantt detallado) -> 17 slides
</commit_message>
<xml_diff>
--- a/Constructibilidad/Análisis generados/Alcance_Especialidades_CPF2.pptx
+++ b/Constructibilidad/Análisis generados/Alcance_Especialidades_CPF2.pptx
@@ -20,6 +20,8 @@
     <p:sldId id="268" r:id="rId19"/>
     <p:sldId id="269" r:id="rId20"/>
     <p:sldId id="270" r:id="rId21"/>
+    <p:sldId id="271" r:id="rId22"/>
+    <p:sldId id="272" r:id="rId23"/>
   </p:sldIdLst>
   <p:sldSz cx="12191695" cy="6858000" type="screen4x3"/>
   <p:notesSz cx="6858000" cy="9144000"/>
@@ -6431,7 +6433,7 @@
                 </a:solidFill>
                 <a:latin typeface="Calibri"/>
               </a:rPr>
-              <a:t>AESA monta sus instrumentos + los de proveedor marcados 'montaje por EPC' (266). Los premontados en skids requieren igual conexionado y loop check.</a:t>
+              <a:t>AESA monta sus instrumentos + los de proveedor 'montaje por EPC' (266). Los premontados en skids los instala el vendor, pero los LOOP CHECKS son alcance AESA.</a:t>
             </a:r>
           </a:p>
         </p:txBody>
@@ -12467,6 +12469,686 @@
 </p:sld>
 </file>
 
+<file path=ppt/slides/slide16.xml><?xml version="1.0" encoding="utf-8"?>
+<p:sld xmlns:a="http://schemas.openxmlformats.org/drawingml/2006/main" xmlns:p="http://schemas.openxmlformats.org/presentationml/2006/main" xmlns:r="http://schemas.openxmlformats.org/officeDocument/2006/relationships">
+  <p:cSld>
+    <p:spTree>
+      <p:nvGrpSpPr>
+        <p:cNvPr id="1" name=""/>
+        <p:cNvGrpSpPr/>
+        <p:nvPr/>
+      </p:nvGrpSpPr>
+      <p:grpSpPr/>
+      <p:sp>
+        <p:nvSpPr>
+          <p:cNvPr id="2" name="Rectangle 1"/>
+          <p:cNvSpPr/>
+          <p:nvPr/>
+        </p:nvSpPr>
+        <p:spPr>
+          <a:xfrm>
+            <a:off x="0" y="0"/>
+            <a:ext cx="12191695" cy="1024128"/>
+          </a:xfrm>
+          <a:prstGeom prst="rect">
+            <a:avLst/>
+          </a:prstGeom>
+          <a:solidFill>
+            <a:srgbClr val="1F3B63"/>
+          </a:solidFill>
+          <a:ln>
+            <a:noFill/>
+          </a:ln>
+          <a:effectLst/>
+        </p:spPr>
+        <p:style>
+          <a:lnRef idx="1">
+            <a:schemeClr val="accent1"/>
+          </a:lnRef>
+          <a:fillRef idx="3">
+            <a:schemeClr val="accent1"/>
+          </a:fillRef>
+          <a:effectRef idx="2">
+            <a:schemeClr val="accent1"/>
+          </a:effectRef>
+          <a:fontRef idx="minor">
+            <a:schemeClr val="lt1"/>
+          </a:fontRef>
+        </p:style>
+        <p:txBody>
+          <a:bodyPr rtlCol="0" anchor="ctr"/>
+          <a:lstStyle/>
+          <a:p>
+            <a:pPr algn="ctr"/>
+          </a:p>
+        </p:txBody>
+      </p:sp>
+      <p:sp>
+        <p:nvSpPr>
+          <p:cNvPr id="3" name="Rectangle 2"/>
+          <p:cNvSpPr/>
+          <p:nvPr/>
+        </p:nvSpPr>
+        <p:spPr>
+          <a:xfrm>
+            <a:off x="0" y="1024128"/>
+            <a:ext cx="12191695" cy="54864"/>
+          </a:xfrm>
+          <a:prstGeom prst="rect">
+            <a:avLst/>
+          </a:prstGeom>
+          <a:solidFill>
+            <a:srgbClr val="1F3B63"/>
+          </a:solidFill>
+          <a:ln>
+            <a:noFill/>
+          </a:ln>
+          <a:effectLst/>
+        </p:spPr>
+        <p:style>
+          <a:lnRef idx="1">
+            <a:schemeClr val="accent1"/>
+          </a:lnRef>
+          <a:fillRef idx="3">
+            <a:schemeClr val="accent1"/>
+          </a:fillRef>
+          <a:effectRef idx="2">
+            <a:schemeClr val="accent1"/>
+          </a:effectRef>
+          <a:fontRef idx="minor">
+            <a:schemeClr val="lt1"/>
+          </a:fontRef>
+        </p:style>
+        <p:txBody>
+          <a:bodyPr rtlCol="0" anchor="ctr"/>
+          <a:lstStyle/>
+          <a:p>
+            <a:pPr algn="ctr"/>
+          </a:p>
+        </p:txBody>
+      </p:sp>
+      <p:sp>
+        <p:nvSpPr>
+          <p:cNvPr id="4" name="TextBox 3"/>
+          <p:cNvSpPr txBox="1"/>
+          <p:nvPr/>
+        </p:nvSpPr>
+        <p:spPr>
+          <a:xfrm>
+            <a:off x="411480" y="109728"/>
+            <a:ext cx="10058400" cy="274320"/>
+          </a:xfrm>
+          <a:prstGeom prst="rect">
+            <a:avLst/>
+          </a:prstGeom>
+          <a:noFill/>
+        </p:spPr>
+        <p:txBody>
+          <a:bodyPr wrap="square" anchor="t" lIns="25400" rIns="25400">
+            <a:spAutoFit/>
+          </a:bodyPr>
+          <a:lstStyle/>
+          <a:p>
+            <a:pPr algn="l"/>
+            <a:r>
+              <a:rPr sz="1100" b="1">
+                <a:solidFill>
+                  <a:srgbClr val="9DB8D8"/>
+                </a:solidFill>
+                <a:latin typeface="Calibri"/>
+              </a:rPr>
+              <a:t>ALCANCE DE ESPECIALIDADES · CPF2 LA CALERA II</a:t>
+            </a:r>
+          </a:p>
+        </p:txBody>
+      </p:sp>
+      <p:sp>
+        <p:nvSpPr>
+          <p:cNvPr id="5" name="TextBox 4"/>
+          <p:cNvSpPr txBox="1"/>
+          <p:nvPr/>
+        </p:nvSpPr>
+        <p:spPr>
+          <a:xfrm>
+            <a:off x="411480" y="365760"/>
+            <a:ext cx="11338560" cy="640080"/>
+          </a:xfrm>
+          <a:prstGeom prst="rect">
+            <a:avLst/>
+          </a:prstGeom>
+          <a:noFill/>
+        </p:spPr>
+        <p:txBody>
+          <a:bodyPr wrap="square" anchor="t" lIns="25400" rIns="25400">
+            <a:spAutoFit/>
+          </a:bodyPr>
+          <a:lstStyle/>
+          <a:p>
+            <a:pPr algn="l"/>
+            <a:r>
+              <a:rPr sz="2500" b="1">
+                <a:solidFill>
+                  <a:srgbClr val="FFFFFF"/>
+                </a:solidFill>
+                <a:latin typeface="Calibri"/>
+              </a:rPr>
+              <a:t>Anexo · Contexto de planta (vista 3D)</a:t>
+            </a:r>
+          </a:p>
+        </p:txBody>
+      </p:sp>
+      <p:sp>
+        <p:nvSpPr>
+          <p:cNvPr id="6" name="TextBox 5"/>
+          <p:cNvSpPr txBox="1"/>
+          <p:nvPr/>
+        </p:nvSpPr>
+        <p:spPr>
+          <a:xfrm>
+            <a:off x="9966960" y="109728"/>
+            <a:ext cx="2011680" cy="274320"/>
+          </a:xfrm>
+          <a:prstGeom prst="rect">
+            <a:avLst/>
+          </a:prstGeom>
+          <a:noFill/>
+        </p:spPr>
+        <p:txBody>
+          <a:bodyPr wrap="square" anchor="t" lIns="25400" rIns="25400">
+            <a:spAutoFit/>
+          </a:bodyPr>
+          <a:lstStyle/>
+          <a:p>
+            <a:pPr algn="r"/>
+            <a:r>
+              <a:rPr sz="1100" b="1">
+                <a:solidFill>
+                  <a:srgbClr val="BF9000"/>
+                </a:solidFill>
+                <a:latin typeface="Calibri"/>
+              </a:rPr>
+              <a:t>RFSU 20-DIC-2027</a:t>
+            </a:r>
+          </a:p>
+        </p:txBody>
+      </p:sp>
+      <p:pic>
+        <p:nvPicPr>
+          <p:cNvPr id="7" name="Picture 6" descr="_t3d.png"/>
+          <p:cNvPicPr>
+            <a:picLocks noChangeAspect="1"/>
+          </p:cNvPicPr>
+          <p:nvPr/>
+        </p:nvPicPr>
+        <p:blipFill>
+          <a:blip r:embed="rId2"/>
+          <a:stretch>
+            <a:fillRect/>
+          </a:stretch>
+        </p:blipFill>
+        <p:spPr>
+          <a:xfrm>
+            <a:off x="4382886" y="1325880"/>
+            <a:ext cx="3425043" cy="4846320"/>
+          </a:xfrm>
+          <a:prstGeom prst="rect">
+            <a:avLst/>
+          </a:prstGeom>
+        </p:spPr>
+      </p:pic>
+      <p:sp>
+        <p:nvSpPr>
+          <p:cNvPr id="8" name="TextBox 7"/>
+          <p:cNvSpPr txBox="1"/>
+          <p:nvPr/>
+        </p:nvSpPr>
+        <p:spPr>
+          <a:xfrm>
+            <a:off x="411480" y="6263640"/>
+            <a:ext cx="11338560" cy="274320"/>
+          </a:xfrm>
+          <a:prstGeom prst="rect">
+            <a:avLst/>
+          </a:prstGeom>
+          <a:noFill/>
+        </p:spPr>
+        <p:txBody>
+          <a:bodyPr wrap="square" anchor="t" lIns="25400" rIns="25400">
+            <a:spAutoFit/>
+          </a:bodyPr>
+          <a:lstStyle/>
+          <a:p>
+            <a:pPr algn="l"/>
+            <a:r>
+              <a:rPr sz="1050" b="0">
+                <a:solidFill>
+                  <a:srgbClr val="595959"/>
+                </a:solidFill>
+                <a:latin typeface="Calibri"/>
+              </a:rPr>
+              <a:t>Modelo 3D CPF2 — escala de volumen y congestión: sustento físico de los volúmenes (cables, puntas, instrumentos) y de los factores de productividad y pico de cuadrillas.</a:t>
+            </a:r>
+          </a:p>
+        </p:txBody>
+      </p:sp>
+      <p:sp>
+        <p:nvSpPr>
+          <p:cNvPr id="9" name="TextBox 8"/>
+          <p:cNvSpPr txBox="1"/>
+          <p:nvPr/>
+        </p:nvSpPr>
+        <p:spPr>
+          <a:xfrm>
+            <a:off x="411480" y="6473952"/>
+            <a:ext cx="8229600" cy="274320"/>
+          </a:xfrm>
+          <a:prstGeom prst="rect">
+            <a:avLst/>
+          </a:prstGeom>
+          <a:noFill/>
+        </p:spPr>
+        <p:txBody>
+          <a:bodyPr wrap="square" anchor="t" lIns="25400" rIns="25400">
+            <a:spAutoFit/>
+          </a:bodyPr>
+          <a:lstStyle/>
+          <a:p>
+            <a:pPr algn="l"/>
+            <a:r>
+              <a:rPr sz="900" b="0">
+                <a:solidFill>
+                  <a:srgbClr val="595959"/>
+                </a:solidFill>
+                <a:latin typeface="Calibri"/>
+              </a:rPr>
+              <a:t>Constructibilidad CPF2 · Alcance por especialidad · Rev. 0 · 13-06-2026</a:t>
+            </a:r>
+          </a:p>
+        </p:txBody>
+      </p:sp>
+      <p:sp>
+        <p:nvSpPr>
+          <p:cNvPr id="10" name="TextBox 9"/>
+          <p:cNvSpPr txBox="1"/>
+          <p:nvPr/>
+        </p:nvSpPr>
+        <p:spPr>
+          <a:xfrm>
+            <a:off x="11155680" y="6473952"/>
+            <a:ext cx="822960" cy="274320"/>
+          </a:xfrm>
+          <a:prstGeom prst="rect">
+            <a:avLst/>
+          </a:prstGeom>
+          <a:noFill/>
+        </p:spPr>
+        <p:txBody>
+          <a:bodyPr wrap="square" anchor="t" lIns="25400" rIns="25400">
+            <a:spAutoFit/>
+          </a:bodyPr>
+          <a:lstStyle/>
+          <a:p>
+            <a:pPr algn="r"/>
+            <a:r>
+              <a:rPr sz="900" b="0">
+                <a:solidFill>
+                  <a:srgbClr val="595959"/>
+                </a:solidFill>
+                <a:latin typeface="Calibri"/>
+              </a:rPr>
+              <a:t>16</a:t>
+            </a:r>
+          </a:p>
+        </p:txBody>
+      </p:sp>
+    </p:spTree>
+  </p:cSld>
+  <p:clrMapOvr>
+    <a:masterClrMapping/>
+  </p:clrMapOvr>
+</p:sld>
+</file>
+
+<file path=ppt/slides/slide17.xml><?xml version="1.0" encoding="utf-8"?>
+<p:sld xmlns:a="http://schemas.openxmlformats.org/drawingml/2006/main" xmlns:p="http://schemas.openxmlformats.org/presentationml/2006/main" xmlns:r="http://schemas.openxmlformats.org/officeDocument/2006/relationships">
+  <p:cSld>
+    <p:spTree>
+      <p:nvGrpSpPr>
+        <p:cNvPr id="1" name=""/>
+        <p:cNvGrpSpPr/>
+        <p:nvPr/>
+      </p:nvGrpSpPr>
+      <p:grpSpPr/>
+      <p:sp>
+        <p:nvSpPr>
+          <p:cNvPr id="2" name="Rectangle 1"/>
+          <p:cNvSpPr/>
+          <p:nvPr/>
+        </p:nvSpPr>
+        <p:spPr>
+          <a:xfrm>
+            <a:off x="0" y="0"/>
+            <a:ext cx="12191695" cy="1024128"/>
+          </a:xfrm>
+          <a:prstGeom prst="rect">
+            <a:avLst/>
+          </a:prstGeom>
+          <a:solidFill>
+            <a:srgbClr val="1F3B63"/>
+          </a:solidFill>
+          <a:ln>
+            <a:noFill/>
+          </a:ln>
+          <a:effectLst/>
+        </p:spPr>
+        <p:style>
+          <a:lnRef idx="1">
+            <a:schemeClr val="accent1"/>
+          </a:lnRef>
+          <a:fillRef idx="3">
+            <a:schemeClr val="accent1"/>
+          </a:fillRef>
+          <a:effectRef idx="2">
+            <a:schemeClr val="accent1"/>
+          </a:effectRef>
+          <a:fontRef idx="minor">
+            <a:schemeClr val="lt1"/>
+          </a:fontRef>
+        </p:style>
+        <p:txBody>
+          <a:bodyPr rtlCol="0" anchor="ctr"/>
+          <a:lstStyle/>
+          <a:p>
+            <a:pPr algn="ctr"/>
+          </a:p>
+        </p:txBody>
+      </p:sp>
+      <p:sp>
+        <p:nvSpPr>
+          <p:cNvPr id="3" name="Rectangle 2"/>
+          <p:cNvSpPr/>
+          <p:nvPr/>
+        </p:nvSpPr>
+        <p:spPr>
+          <a:xfrm>
+            <a:off x="0" y="1024128"/>
+            <a:ext cx="12191695" cy="54864"/>
+          </a:xfrm>
+          <a:prstGeom prst="rect">
+            <a:avLst/>
+          </a:prstGeom>
+          <a:solidFill>
+            <a:srgbClr val="1F3B63"/>
+          </a:solidFill>
+          <a:ln>
+            <a:noFill/>
+          </a:ln>
+          <a:effectLst/>
+        </p:spPr>
+        <p:style>
+          <a:lnRef idx="1">
+            <a:schemeClr val="accent1"/>
+          </a:lnRef>
+          <a:fillRef idx="3">
+            <a:schemeClr val="accent1"/>
+          </a:fillRef>
+          <a:effectRef idx="2">
+            <a:schemeClr val="accent1"/>
+          </a:effectRef>
+          <a:fontRef idx="minor">
+            <a:schemeClr val="lt1"/>
+          </a:fontRef>
+        </p:style>
+        <p:txBody>
+          <a:bodyPr rtlCol="0" anchor="ctr"/>
+          <a:lstStyle/>
+          <a:p>
+            <a:pPr algn="ctr"/>
+          </a:p>
+        </p:txBody>
+      </p:sp>
+      <p:sp>
+        <p:nvSpPr>
+          <p:cNvPr id="4" name="TextBox 3"/>
+          <p:cNvSpPr txBox="1"/>
+          <p:nvPr/>
+        </p:nvSpPr>
+        <p:spPr>
+          <a:xfrm>
+            <a:off x="411480" y="109728"/>
+            <a:ext cx="10058400" cy="274320"/>
+          </a:xfrm>
+          <a:prstGeom prst="rect">
+            <a:avLst/>
+          </a:prstGeom>
+          <a:noFill/>
+        </p:spPr>
+        <p:txBody>
+          <a:bodyPr wrap="square" anchor="t" lIns="25400" rIns="25400">
+            <a:spAutoFit/>
+          </a:bodyPr>
+          <a:lstStyle/>
+          <a:p>
+            <a:pPr algn="l"/>
+            <a:r>
+              <a:rPr sz="1100" b="1">
+                <a:solidFill>
+                  <a:srgbClr val="9DB8D8"/>
+                </a:solidFill>
+                <a:latin typeface="Calibri"/>
+              </a:rPr>
+              <a:t>ALCANCE DE ESPECIALIDADES · CPF2 LA CALERA II</a:t>
+            </a:r>
+          </a:p>
+        </p:txBody>
+      </p:sp>
+      <p:sp>
+        <p:nvSpPr>
+          <p:cNvPr id="5" name="TextBox 4"/>
+          <p:cNvSpPr txBox="1"/>
+          <p:nvPr/>
+        </p:nvSpPr>
+        <p:spPr>
+          <a:xfrm>
+            <a:off x="411480" y="365760"/>
+            <a:ext cx="11338560" cy="640080"/>
+          </a:xfrm>
+          <a:prstGeom prst="rect">
+            <a:avLst/>
+          </a:prstGeom>
+          <a:noFill/>
+        </p:spPr>
+        <p:txBody>
+          <a:bodyPr wrap="square" anchor="t" lIns="25400" rIns="25400">
+            <a:spAutoFit/>
+          </a:bodyPr>
+          <a:lstStyle/>
+          <a:p>
+            <a:pPr algn="l"/>
+            <a:r>
+              <a:rPr sz="2500" b="1">
+                <a:solidFill>
+                  <a:srgbClr val="FFFFFF"/>
+                </a:solidFill>
+                <a:latin typeface="Calibri"/>
+              </a:rPr>
+              <a:t>Anexo · Cronograma detallado (Gantt INS+EL)</a:t>
+            </a:r>
+          </a:p>
+        </p:txBody>
+      </p:sp>
+      <p:sp>
+        <p:nvSpPr>
+          <p:cNvPr id="6" name="TextBox 5"/>
+          <p:cNvSpPr txBox="1"/>
+          <p:nvPr/>
+        </p:nvSpPr>
+        <p:spPr>
+          <a:xfrm>
+            <a:off x="9966960" y="109728"/>
+            <a:ext cx="2011680" cy="274320"/>
+          </a:xfrm>
+          <a:prstGeom prst="rect">
+            <a:avLst/>
+          </a:prstGeom>
+          <a:noFill/>
+        </p:spPr>
+        <p:txBody>
+          <a:bodyPr wrap="square" anchor="t" lIns="25400" rIns="25400">
+            <a:spAutoFit/>
+          </a:bodyPr>
+          <a:lstStyle/>
+          <a:p>
+            <a:pPr algn="r"/>
+            <a:r>
+              <a:rPr sz="1100" b="1">
+                <a:solidFill>
+                  <a:srgbClr val="BF9000"/>
+                </a:solidFill>
+                <a:latin typeface="Calibri"/>
+              </a:rPr>
+              <a:t>RFSU 20-DIC-2027</a:t>
+            </a:r>
+          </a:p>
+        </p:txBody>
+      </p:sp>
+      <p:pic>
+        <p:nvPicPr>
+          <p:cNvPr id="7" name="Picture 6" descr="_tg.png"/>
+          <p:cNvPicPr>
+            <a:picLocks noChangeAspect="1"/>
+          </p:cNvPicPr>
+          <p:nvPr/>
+        </p:nvPicPr>
+        <p:blipFill>
+          <a:blip r:embed="rId2"/>
+          <a:stretch>
+            <a:fillRect/>
+          </a:stretch>
+        </p:blipFill>
+        <p:spPr>
+          <a:xfrm>
+            <a:off x="2604145" y="1280160"/>
+            <a:ext cx="6983403" cy="4937760"/>
+          </a:xfrm>
+          <a:prstGeom prst="rect">
+            <a:avLst/>
+          </a:prstGeom>
+        </p:spPr>
+      </p:pic>
+      <p:sp>
+        <p:nvSpPr>
+          <p:cNvPr id="8" name="TextBox 7"/>
+          <p:cNvSpPr txBox="1"/>
+          <p:nvPr/>
+        </p:nvSpPr>
+        <p:spPr>
+          <a:xfrm>
+            <a:off x="411480" y="6355080"/>
+            <a:ext cx="11338560" cy="274320"/>
+          </a:xfrm>
+          <a:prstGeom prst="rect">
+            <a:avLst/>
+          </a:prstGeom>
+          <a:noFill/>
+        </p:spPr>
+        <p:txBody>
+          <a:bodyPr wrap="square" anchor="t" lIns="25400" rIns="25400">
+            <a:spAutoFit/>
+          </a:bodyPr>
+          <a:lstStyle/>
+          <a:p>
+            <a:pPr algn="l"/>
+            <a:r>
+              <a:rPr sz="1050" b="0">
+                <a:solidFill>
+                  <a:srgbClr val="595959"/>
+                </a:solidFill>
+                <a:latin typeface="Calibri"/>
+              </a:rPr>
+              <a:t>Detalle en Cronograma_INS_EL_CPF2.pdf (Gantt + tabla de tareas + bases). RFSU 20-DIC-2027.</a:t>
+            </a:r>
+          </a:p>
+        </p:txBody>
+      </p:sp>
+      <p:sp>
+        <p:nvSpPr>
+          <p:cNvPr id="9" name="TextBox 8"/>
+          <p:cNvSpPr txBox="1"/>
+          <p:nvPr/>
+        </p:nvSpPr>
+        <p:spPr>
+          <a:xfrm>
+            <a:off x="411480" y="6473952"/>
+            <a:ext cx="8229600" cy="274320"/>
+          </a:xfrm>
+          <a:prstGeom prst="rect">
+            <a:avLst/>
+          </a:prstGeom>
+          <a:noFill/>
+        </p:spPr>
+        <p:txBody>
+          <a:bodyPr wrap="square" anchor="t" lIns="25400" rIns="25400">
+            <a:spAutoFit/>
+          </a:bodyPr>
+          <a:lstStyle/>
+          <a:p>
+            <a:pPr algn="l"/>
+            <a:r>
+              <a:rPr sz="900" b="0">
+                <a:solidFill>
+                  <a:srgbClr val="595959"/>
+                </a:solidFill>
+                <a:latin typeface="Calibri"/>
+              </a:rPr>
+              <a:t>Constructibilidad CPF2 · Alcance por especialidad · Rev. 0 · 13-06-2026</a:t>
+            </a:r>
+          </a:p>
+        </p:txBody>
+      </p:sp>
+      <p:sp>
+        <p:nvSpPr>
+          <p:cNvPr id="10" name="TextBox 9"/>
+          <p:cNvSpPr txBox="1"/>
+          <p:nvPr/>
+        </p:nvSpPr>
+        <p:spPr>
+          <a:xfrm>
+            <a:off x="11155680" y="6473952"/>
+            <a:ext cx="822960" cy="274320"/>
+          </a:xfrm>
+          <a:prstGeom prst="rect">
+            <a:avLst/>
+          </a:prstGeom>
+          <a:noFill/>
+        </p:spPr>
+        <p:txBody>
+          <a:bodyPr wrap="square" anchor="t" lIns="25400" rIns="25400">
+            <a:spAutoFit/>
+          </a:bodyPr>
+          <a:lstStyle/>
+          <a:p>
+            <a:pPr algn="r"/>
+            <a:r>
+              <a:rPr sz="900" b="0">
+                <a:solidFill>
+                  <a:srgbClr val="595959"/>
+                </a:solidFill>
+                <a:latin typeface="Calibri"/>
+              </a:rPr>
+              <a:t>17</a:t>
+            </a:r>
+          </a:p>
+        </p:txBody>
+      </p:sp>
+    </p:spTree>
+  </p:cSld>
+  <p:clrMapOvr>
+    <a:masterClrMapping/>
+  </p:clrMapOvr>
+</p:sld>
+</file>
+
 <file path=ppt/slides/slide2.xml><?xml version="1.0" encoding="utf-8"?>
 <p:sld xmlns:a="http://schemas.openxmlformats.org/drawingml/2006/main" xmlns:p="http://schemas.openxmlformats.org/presentationml/2006/main" xmlns:r="http://schemas.openxmlformats.org/officeDocument/2006/relationships">
   <p:cSld>
@@ -18438,7 +19120,7 @@
                           </a:solidFill>
                           <a:latin typeface="Calibri"/>
                         </a:rPr>
-                        <a:t>Inauco / HIMA</a:t>
+                        <a:t>HIMA</a:t>
                       </a:r>
                     </a:p>
                   </a:txBody>
@@ -18485,7 +19167,7 @@
                           </a:solidFill>
                           <a:latin typeface="Calibri"/>
                         </a:rPr>
-                        <a:t>Fuego y Gas — 120 dispositivos de campo</a:t>
+                        <a:t>Fuego y Gas — detectores de campo + hardware</a:t>
                       </a:r>
                     </a:p>
                   </a:txBody>
@@ -18500,7 +19182,7 @@
                     <a:bodyPr wrap="square"/>
                     <a:lstStyle/>
                     <a:p>
-                      <a:pPr algn="ctr"/>
+                      <a:pPr algn="l"/>
                       <a:r>
                         <a:rPr sz="1150">
                           <a:solidFill>
@@ -18508,7 +19190,7 @@
                           </a:solidFill>
                           <a:latin typeface="Calibri"/>
                         </a:rPr>
-                        <a:t>AESA</a:t>
+                        <a:t>AESA (det.) / HIMA (HW)</a:t>
                       </a:r>
                     </a:p>
                   </a:txBody>

</xml_diff>

<commit_message>
Presentacion 2: slide final de ruta critica transversal (EL/IN/Precom)
- Diagrama de flujo (chevrons) del frente critico EL->Pruebas->Comisionado hasta RFSU
- Lane IN convergente (loop check listo) al comisionado integrado
- Nota con cadena critica, gatillos y restricciones observadas a hoy
- 18 slides
</commit_message>
<xml_diff>
--- a/Constructibilidad/Análisis generados/Alcance_Especialidades_CPF2.pptx
+++ b/Constructibilidad/Análisis generados/Alcance_Especialidades_CPF2.pptx
@@ -22,6 +22,7 @@
     <p:sldId id="270" r:id="rId21"/>
     <p:sldId id="271" r:id="rId22"/>
     <p:sldId id="272" r:id="rId23"/>
+    <p:sldId id="273" r:id="rId24"/>
   </p:sldIdLst>
   <p:sldSz cx="12191695" cy="6858000" type="screen4x3"/>
   <p:notesSz cx="6858000" cy="9144000"/>
@@ -13137,6 +13138,1355 @@
                 <a:latin typeface="Calibri"/>
               </a:rPr>
               <a:t>17</a:t>
+            </a:r>
+          </a:p>
+        </p:txBody>
+      </p:sp>
+    </p:spTree>
+  </p:cSld>
+  <p:clrMapOvr>
+    <a:masterClrMapping/>
+  </p:clrMapOvr>
+</p:sld>
+</file>
+
+<file path=ppt/slides/slide18.xml><?xml version="1.0" encoding="utf-8"?>
+<p:sld xmlns:a="http://schemas.openxmlformats.org/drawingml/2006/main" xmlns:p="http://schemas.openxmlformats.org/presentationml/2006/main" xmlns:r="http://schemas.openxmlformats.org/officeDocument/2006/relationships">
+  <p:cSld>
+    <p:spTree>
+      <p:nvGrpSpPr>
+        <p:cNvPr id="1" name=""/>
+        <p:cNvGrpSpPr/>
+        <p:nvPr/>
+      </p:nvGrpSpPr>
+      <p:grpSpPr/>
+      <p:sp>
+        <p:nvSpPr>
+          <p:cNvPr id="2" name="Rectangle 1"/>
+          <p:cNvSpPr/>
+          <p:nvPr/>
+        </p:nvSpPr>
+        <p:spPr>
+          <a:xfrm>
+            <a:off x="0" y="0"/>
+            <a:ext cx="12191695" cy="1024128"/>
+          </a:xfrm>
+          <a:prstGeom prst="rect">
+            <a:avLst/>
+          </a:prstGeom>
+          <a:solidFill>
+            <a:srgbClr val="1F3B63"/>
+          </a:solidFill>
+          <a:ln>
+            <a:noFill/>
+          </a:ln>
+          <a:effectLst/>
+        </p:spPr>
+        <p:style>
+          <a:lnRef idx="1">
+            <a:schemeClr val="accent1"/>
+          </a:lnRef>
+          <a:fillRef idx="3">
+            <a:schemeClr val="accent1"/>
+          </a:fillRef>
+          <a:effectRef idx="2">
+            <a:schemeClr val="accent1"/>
+          </a:effectRef>
+          <a:fontRef idx="minor">
+            <a:schemeClr val="lt1"/>
+          </a:fontRef>
+        </p:style>
+        <p:txBody>
+          <a:bodyPr rtlCol="0" anchor="ctr"/>
+          <a:lstStyle/>
+          <a:p>
+            <a:pPr algn="ctr"/>
+          </a:p>
+        </p:txBody>
+      </p:sp>
+      <p:sp>
+        <p:nvSpPr>
+          <p:cNvPr id="3" name="Rectangle 2"/>
+          <p:cNvSpPr/>
+          <p:nvPr/>
+        </p:nvSpPr>
+        <p:spPr>
+          <a:xfrm>
+            <a:off x="0" y="1024128"/>
+            <a:ext cx="12191695" cy="54864"/>
+          </a:xfrm>
+          <a:prstGeom prst="rect">
+            <a:avLst/>
+          </a:prstGeom>
+          <a:solidFill>
+            <a:srgbClr val="C00000"/>
+          </a:solidFill>
+          <a:ln>
+            <a:noFill/>
+          </a:ln>
+          <a:effectLst/>
+        </p:spPr>
+        <p:style>
+          <a:lnRef idx="1">
+            <a:schemeClr val="accent1"/>
+          </a:lnRef>
+          <a:fillRef idx="3">
+            <a:schemeClr val="accent1"/>
+          </a:fillRef>
+          <a:effectRef idx="2">
+            <a:schemeClr val="accent1"/>
+          </a:effectRef>
+          <a:fontRef idx="minor">
+            <a:schemeClr val="lt1"/>
+          </a:fontRef>
+        </p:style>
+        <p:txBody>
+          <a:bodyPr rtlCol="0" anchor="ctr"/>
+          <a:lstStyle/>
+          <a:p>
+            <a:pPr algn="ctr"/>
+          </a:p>
+        </p:txBody>
+      </p:sp>
+      <p:sp>
+        <p:nvSpPr>
+          <p:cNvPr id="4" name="TextBox 3"/>
+          <p:cNvSpPr txBox="1"/>
+          <p:nvPr/>
+        </p:nvSpPr>
+        <p:spPr>
+          <a:xfrm>
+            <a:off x="411480" y="109728"/>
+            <a:ext cx="10058400" cy="274320"/>
+          </a:xfrm>
+          <a:prstGeom prst="rect">
+            <a:avLst/>
+          </a:prstGeom>
+          <a:noFill/>
+        </p:spPr>
+        <p:txBody>
+          <a:bodyPr wrap="square" anchor="t" lIns="25400" rIns="25400">
+            <a:spAutoFit/>
+          </a:bodyPr>
+          <a:lstStyle/>
+          <a:p>
+            <a:pPr algn="l"/>
+            <a:r>
+              <a:rPr sz="1100" b="1">
+                <a:solidFill>
+                  <a:srgbClr val="9DB8D8"/>
+                </a:solidFill>
+                <a:latin typeface="Calibri"/>
+              </a:rPr>
+              <a:t>ALCANCE DE ESPECIALIDADES · CPF2 LA CALERA II</a:t>
+            </a:r>
+          </a:p>
+        </p:txBody>
+      </p:sp>
+      <p:sp>
+        <p:nvSpPr>
+          <p:cNvPr id="5" name="TextBox 4"/>
+          <p:cNvSpPr txBox="1"/>
+          <p:nvPr/>
+        </p:nvSpPr>
+        <p:spPr>
+          <a:xfrm>
+            <a:off x="411480" y="365760"/>
+            <a:ext cx="11338560" cy="640080"/>
+          </a:xfrm>
+          <a:prstGeom prst="rect">
+            <a:avLst/>
+          </a:prstGeom>
+          <a:noFill/>
+        </p:spPr>
+        <p:txBody>
+          <a:bodyPr wrap="square" anchor="t" lIns="25400" rIns="25400">
+            <a:spAutoFit/>
+          </a:bodyPr>
+          <a:lstStyle/>
+          <a:p>
+            <a:pPr algn="l"/>
+            <a:r>
+              <a:rPr sz="2500" b="1">
+                <a:solidFill>
+                  <a:srgbClr val="FFFFFF"/>
+                </a:solidFill>
+                <a:latin typeface="Calibri"/>
+              </a:rPr>
+              <a:t>Ruta crítica — visión transversal EL · IN · Precom (a hoy)</a:t>
+            </a:r>
+          </a:p>
+        </p:txBody>
+      </p:sp>
+      <p:sp>
+        <p:nvSpPr>
+          <p:cNvPr id="6" name="TextBox 5"/>
+          <p:cNvSpPr txBox="1"/>
+          <p:nvPr/>
+        </p:nvSpPr>
+        <p:spPr>
+          <a:xfrm>
+            <a:off x="9966960" y="109728"/>
+            <a:ext cx="2011680" cy="274320"/>
+          </a:xfrm>
+          <a:prstGeom prst="rect">
+            <a:avLst/>
+          </a:prstGeom>
+          <a:noFill/>
+        </p:spPr>
+        <p:txBody>
+          <a:bodyPr wrap="square" anchor="t" lIns="25400" rIns="25400">
+            <a:spAutoFit/>
+          </a:bodyPr>
+          <a:lstStyle/>
+          <a:p>
+            <a:pPr algn="r"/>
+            <a:r>
+              <a:rPr sz="1100" b="1">
+                <a:solidFill>
+                  <a:srgbClr val="BF9000"/>
+                </a:solidFill>
+                <a:latin typeface="Calibri"/>
+              </a:rPr>
+              <a:t>RFSU 20-DIC-2027</a:t>
+            </a:r>
+          </a:p>
+        </p:txBody>
+      </p:sp>
+      <p:sp>
+        <p:nvSpPr>
+          <p:cNvPr id="7" name="TextBox 6"/>
+          <p:cNvSpPr txBox="1"/>
+          <p:nvPr/>
+        </p:nvSpPr>
+        <p:spPr>
+          <a:xfrm>
+            <a:off x="411480" y="1207008"/>
+            <a:ext cx="11338560" cy="274320"/>
+          </a:xfrm>
+          <a:prstGeom prst="rect">
+            <a:avLst/>
+          </a:prstGeom>
+          <a:noFill/>
+        </p:spPr>
+        <p:txBody>
+          <a:bodyPr wrap="square" anchor="t" lIns="25400" rIns="25400">
+            <a:spAutoFit/>
+          </a:bodyPr>
+          <a:lstStyle/>
+          <a:p>
+            <a:pPr algn="l"/>
+            <a:r>
+              <a:rPr sz="1200" b="0">
+                <a:solidFill>
+                  <a:srgbClr val="595959"/>
+                </a:solidFill>
+                <a:latin typeface="Calibri"/>
+              </a:rPr>
+              <a:t>Cadena que gobierna el RFSU según lo observado al 13-06-2026 — cruza Electricidad, Instrumentación y Precomisionado</a:t>
+            </a:r>
+          </a:p>
+        </p:txBody>
+      </p:sp>
+      <p:sp>
+        <p:nvSpPr>
+          <p:cNvPr id="8" name="TextBox 7"/>
+          <p:cNvSpPr txBox="1"/>
+          <p:nvPr/>
+        </p:nvSpPr>
+        <p:spPr>
+          <a:xfrm>
+            <a:off x="411480" y="1691640"/>
+            <a:ext cx="9144000" cy="274320"/>
+          </a:xfrm>
+          <a:prstGeom prst="rect">
+            <a:avLst/>
+          </a:prstGeom>
+          <a:noFill/>
+        </p:spPr>
+        <p:txBody>
+          <a:bodyPr wrap="square" anchor="t" lIns="25400" rIns="25400">
+            <a:spAutoFit/>
+          </a:bodyPr>
+          <a:lstStyle/>
+          <a:p>
+            <a:pPr algn="l"/>
+            <a:r>
+              <a:rPr sz="1150" b="1">
+                <a:solidFill>
+                  <a:srgbClr val="C55A11"/>
+                </a:solidFill>
+                <a:latin typeface="Calibri"/>
+              </a:rPr>
+              <a:t>FRENTE CRÍTICO  ·  Eléctrico → Pruebas → Comisionado</a:t>
+            </a:r>
+          </a:p>
+        </p:txBody>
+      </p:sp>
+      <p:sp>
+        <p:nvSpPr>
+          <p:cNvPr id="9" name="Chevron 8"/>
+          <p:cNvSpPr/>
+          <p:nvPr/>
+        </p:nvSpPr>
+        <p:spPr>
+          <a:xfrm>
+            <a:off x="411480" y="2011680"/>
+            <a:ext cx="1481328" cy="960120"/>
+          </a:xfrm>
+          <a:prstGeom prst="chevron">
+            <a:avLst/>
+          </a:prstGeom>
+          <a:solidFill>
+            <a:srgbClr val="C55A11"/>
+          </a:solidFill>
+          <a:ln>
+            <a:noFill/>
+          </a:ln>
+          <a:effectLst/>
+        </p:spPr>
+        <p:style>
+          <a:lnRef idx="1">
+            <a:schemeClr val="accent1"/>
+          </a:lnRef>
+          <a:fillRef idx="3">
+            <a:schemeClr val="accent1"/>
+          </a:fillRef>
+          <a:effectRef idx="2">
+            <a:schemeClr val="accent1"/>
+          </a:effectRef>
+          <a:fontRef idx="minor">
+            <a:schemeClr val="lt1"/>
+          </a:fontRef>
+        </p:style>
+        <p:txBody>
+          <a:bodyPr rtlCol="0" anchor="ctr" wrap="square" lIns="127000" rIns="152400" tIns="12700" bIns="12700"/>
+          <a:lstStyle/>
+          <a:p>
+            <a:pPr algn="ctr"/>
+            <a:r>
+              <a:rPr sz="1050" b="1">
+                <a:solidFill>
+                  <a:srgbClr val="FFFFFF"/>
+                </a:solidFill>
+                <a:latin typeface="Calibri"/>
+              </a:rPr>
+              <a:t>SE#3</a:t>
+            </a:r>
+          </a:p>
+          <a:p>
+            <a:pPr algn="ctr"/>
+            <a:r>
+              <a:rPr sz="850" b="0">
+                <a:solidFill>
+                  <a:srgbClr val="FFFFFF"/>
+                </a:solidFill>
+                <a:latin typeface="Calibri"/>
+              </a:rPr>
+              <a:t>14-MAY</a:t>
+            </a:r>
+          </a:p>
+        </p:txBody>
+      </p:sp>
+      <p:sp>
+        <p:nvSpPr>
+          <p:cNvPr id="10" name="Chevron 9"/>
+          <p:cNvSpPr/>
+          <p:nvPr/>
+        </p:nvSpPr>
+        <p:spPr>
+          <a:xfrm>
+            <a:off x="1709928" y="2011680"/>
+            <a:ext cx="1481328" cy="960120"/>
+          </a:xfrm>
+          <a:prstGeom prst="chevron">
+            <a:avLst/>
+          </a:prstGeom>
+          <a:solidFill>
+            <a:srgbClr val="C55A11"/>
+          </a:solidFill>
+          <a:ln>
+            <a:noFill/>
+          </a:ln>
+          <a:effectLst/>
+        </p:spPr>
+        <p:style>
+          <a:lnRef idx="1">
+            <a:schemeClr val="accent1"/>
+          </a:lnRef>
+          <a:fillRef idx="3">
+            <a:schemeClr val="accent1"/>
+          </a:fillRef>
+          <a:effectRef idx="2">
+            <a:schemeClr val="accent1"/>
+          </a:effectRef>
+          <a:fontRef idx="minor">
+            <a:schemeClr val="lt1"/>
+          </a:fontRef>
+        </p:style>
+        <p:txBody>
+          <a:bodyPr rtlCol="0" anchor="ctr" wrap="square" lIns="127000" rIns="152400" tIns="12700" bIns="12700"/>
+          <a:lstStyle/>
+          <a:p>
+            <a:pPr algn="ctr"/>
+            <a:r>
+              <a:rPr sz="1050" b="1">
+                <a:solidFill>
+                  <a:srgbClr val="FFFFFF"/>
+                </a:solidFill>
+                <a:latin typeface="Calibri"/>
+              </a:rPr>
+              <a:t>Armado 21 d</a:t>
+            </a:r>
+          </a:p>
+          <a:p>
+            <a:pPr algn="ctr"/>
+            <a:r>
+              <a:rPr sz="850" b="0">
+                <a:solidFill>
+                  <a:srgbClr val="FFFFFF"/>
+                </a:solidFill>
+                <a:latin typeface="Calibri"/>
+              </a:rPr>
+              <a:t>→03-JUN</a:t>
+            </a:r>
+          </a:p>
+        </p:txBody>
+      </p:sp>
+      <p:sp>
+        <p:nvSpPr>
+          <p:cNvPr id="11" name="Chevron 10"/>
+          <p:cNvSpPr/>
+          <p:nvPr/>
+        </p:nvSpPr>
+        <p:spPr>
+          <a:xfrm>
+            <a:off x="3008376" y="2011680"/>
+            <a:ext cx="1481328" cy="960120"/>
+          </a:xfrm>
+          <a:prstGeom prst="chevron">
+            <a:avLst/>
+          </a:prstGeom>
+          <a:solidFill>
+            <a:srgbClr val="C55A11"/>
+          </a:solidFill>
+          <a:ln>
+            <a:noFill/>
+          </a:ln>
+          <a:effectLst/>
+        </p:spPr>
+        <p:style>
+          <a:lnRef idx="1">
+            <a:schemeClr val="accent1"/>
+          </a:lnRef>
+          <a:fillRef idx="3">
+            <a:schemeClr val="accent1"/>
+          </a:fillRef>
+          <a:effectRef idx="2">
+            <a:schemeClr val="accent1"/>
+          </a:effectRef>
+          <a:fontRef idx="minor">
+            <a:schemeClr val="lt1"/>
+          </a:fontRef>
+        </p:style>
+        <p:txBody>
+          <a:bodyPr rtlCol="0" anchor="ctr" wrap="square" lIns="127000" rIns="152400" tIns="12700" bIns="12700"/>
+          <a:lstStyle/>
+          <a:p>
+            <a:pPr algn="ctr"/>
+            <a:r>
+              <a:rPr sz="1050" b="1">
+                <a:solidFill>
+                  <a:srgbClr val="FFFFFF"/>
+                </a:solidFill>
+                <a:latin typeface="Calibri"/>
+              </a:rPr>
+              <a:t>Conexion. EL 51 d</a:t>
+            </a:r>
+          </a:p>
+          <a:p>
+            <a:pPr algn="ctr"/>
+            <a:r>
+              <a:rPr sz="850" b="0">
+                <a:solidFill>
+                  <a:srgbClr val="FFFFFF"/>
+                </a:solidFill>
+                <a:latin typeface="Calibri"/>
+              </a:rPr>
+              <a:t>→25-JUL</a:t>
+            </a:r>
+          </a:p>
+        </p:txBody>
+      </p:sp>
+      <p:sp>
+        <p:nvSpPr>
+          <p:cNvPr id="12" name="Chevron 11"/>
+          <p:cNvSpPr/>
+          <p:nvPr/>
+        </p:nvSpPr>
+        <p:spPr>
+          <a:xfrm>
+            <a:off x="4306824" y="2011680"/>
+            <a:ext cx="1481328" cy="960120"/>
+          </a:xfrm>
+          <a:prstGeom prst="chevron">
+            <a:avLst/>
+          </a:prstGeom>
+          <a:solidFill>
+            <a:srgbClr val="548235"/>
+          </a:solidFill>
+          <a:ln>
+            <a:noFill/>
+          </a:ln>
+          <a:effectLst/>
+        </p:spPr>
+        <p:style>
+          <a:lnRef idx="1">
+            <a:schemeClr val="accent1"/>
+          </a:lnRef>
+          <a:fillRef idx="3">
+            <a:schemeClr val="accent1"/>
+          </a:fillRef>
+          <a:effectRef idx="2">
+            <a:schemeClr val="accent1"/>
+          </a:effectRef>
+          <a:fontRef idx="minor">
+            <a:schemeClr val="lt1"/>
+          </a:fontRef>
+        </p:style>
+        <p:txBody>
+          <a:bodyPr rtlCol="0" anchor="ctr" wrap="square" lIns="127000" rIns="152400" tIns="12700" bIns="12700"/>
+          <a:lstStyle/>
+          <a:p>
+            <a:pPr algn="ctr"/>
+            <a:r>
+              <a:rPr sz="1050" b="1">
+                <a:solidFill>
+                  <a:srgbClr val="FFFFFF"/>
+                </a:solidFill>
+                <a:latin typeface="Calibri"/>
+              </a:rPr>
+              <a:t>Megger 21 d</a:t>
+            </a:r>
+          </a:p>
+          <a:p>
+            <a:pPr algn="ctr"/>
+            <a:r>
+              <a:rPr sz="850" b="0">
+                <a:solidFill>
+                  <a:srgbClr val="FFFFFF"/>
+                </a:solidFill>
+                <a:latin typeface="Calibri"/>
+              </a:rPr>
+              <a:t>→15-AGO</a:t>
+            </a:r>
+          </a:p>
+        </p:txBody>
+      </p:sp>
+      <p:sp>
+        <p:nvSpPr>
+          <p:cNvPr id="13" name="Chevron 12"/>
+          <p:cNvSpPr/>
+          <p:nvPr/>
+        </p:nvSpPr>
+        <p:spPr>
+          <a:xfrm>
+            <a:off x="5605272" y="2011680"/>
+            <a:ext cx="1481328" cy="960120"/>
+          </a:xfrm>
+          <a:prstGeom prst="chevron">
+            <a:avLst/>
+          </a:prstGeom>
+          <a:solidFill>
+            <a:srgbClr val="548235"/>
+          </a:solidFill>
+          <a:ln>
+            <a:noFill/>
+          </a:ln>
+          <a:effectLst/>
+        </p:spPr>
+        <p:style>
+          <a:lnRef idx="1">
+            <a:schemeClr val="accent1"/>
+          </a:lnRef>
+          <a:fillRef idx="3">
+            <a:schemeClr val="accent1"/>
+          </a:fillRef>
+          <a:effectRef idx="2">
+            <a:schemeClr val="accent1"/>
+          </a:effectRef>
+          <a:fontRef idx="minor">
+            <a:schemeClr val="lt1"/>
+          </a:fontRef>
+        </p:style>
+        <p:txBody>
+          <a:bodyPr rtlCol="0" anchor="ctr" wrap="square" lIns="127000" rIns="152400" tIns="12700" bIns="12700"/>
+          <a:lstStyle/>
+          <a:p>
+            <a:pPr algn="ctr"/>
+            <a:r>
+              <a:rPr sz="1050" b="1">
+                <a:solidFill>
+                  <a:srgbClr val="FFFFFF"/>
+                </a:solidFill>
+                <a:latin typeface="Calibri"/>
+              </a:rPr>
+              <a:t>Energiz. 17 d</a:t>
+            </a:r>
+          </a:p>
+          <a:p>
+            <a:pPr algn="ctr"/>
+            <a:r>
+              <a:rPr sz="850" b="0">
+                <a:solidFill>
+                  <a:srgbClr val="FFFFFF"/>
+                </a:solidFill>
+                <a:latin typeface="Calibri"/>
+              </a:rPr>
+              <a:t>→01-SEP</a:t>
+            </a:r>
+          </a:p>
+        </p:txBody>
+      </p:sp>
+      <p:sp>
+        <p:nvSpPr>
+          <p:cNvPr id="14" name="Chevron 13"/>
+          <p:cNvSpPr/>
+          <p:nvPr/>
+        </p:nvSpPr>
+        <p:spPr>
+          <a:xfrm>
+            <a:off x="6903720" y="2011680"/>
+            <a:ext cx="1481328" cy="960120"/>
+          </a:xfrm>
+          <a:prstGeom prst="chevron">
+            <a:avLst/>
+          </a:prstGeom>
+          <a:solidFill>
+            <a:srgbClr val="548235"/>
+          </a:solidFill>
+          <a:ln>
+            <a:noFill/>
+          </a:ln>
+          <a:effectLst/>
+        </p:spPr>
+        <p:style>
+          <a:lnRef idx="1">
+            <a:schemeClr val="accent1"/>
+          </a:lnRef>
+          <a:fillRef idx="3">
+            <a:schemeClr val="accent1"/>
+          </a:fillRef>
+          <a:effectRef idx="2">
+            <a:schemeClr val="accent1"/>
+          </a:effectRef>
+          <a:fontRef idx="minor">
+            <a:schemeClr val="lt1"/>
+          </a:fontRef>
+        </p:style>
+        <p:txBody>
+          <a:bodyPr rtlCol="0" anchor="ctr" wrap="square" lIns="127000" rIns="152400" tIns="12700" bIns="12700"/>
+          <a:lstStyle/>
+          <a:p>
+            <a:pPr algn="ctr"/>
+            <a:r>
+              <a:rPr sz="1050" b="1">
+                <a:solidFill>
+                  <a:srgbClr val="FFFFFF"/>
+                </a:solidFill>
+                <a:latin typeface="Calibri"/>
+              </a:rPr>
+              <a:t>Precom 21 d</a:t>
+            </a:r>
+          </a:p>
+          <a:p>
+            <a:pPr algn="ctr"/>
+            <a:r>
+              <a:rPr sz="850" b="0">
+                <a:solidFill>
+                  <a:srgbClr val="FFFFFF"/>
+                </a:solidFill>
+                <a:latin typeface="Calibri"/>
+              </a:rPr>
+              <a:t>→22-SEP</a:t>
+            </a:r>
+          </a:p>
+        </p:txBody>
+      </p:sp>
+      <p:sp>
+        <p:nvSpPr>
+          <p:cNvPr id="15" name="Chevron 14"/>
+          <p:cNvSpPr/>
+          <p:nvPr/>
+        </p:nvSpPr>
+        <p:spPr>
+          <a:xfrm>
+            <a:off x="8202168" y="2011680"/>
+            <a:ext cx="1481328" cy="960120"/>
+          </a:xfrm>
+          <a:prstGeom prst="chevron">
+            <a:avLst/>
+          </a:prstGeom>
+          <a:solidFill>
+            <a:srgbClr val="548235"/>
+          </a:solidFill>
+          <a:ln>
+            <a:noFill/>
+          </a:ln>
+          <a:effectLst/>
+        </p:spPr>
+        <p:style>
+          <a:lnRef idx="1">
+            <a:schemeClr val="accent1"/>
+          </a:lnRef>
+          <a:fillRef idx="3">
+            <a:schemeClr val="accent1"/>
+          </a:fillRef>
+          <a:effectRef idx="2">
+            <a:schemeClr val="accent1"/>
+          </a:effectRef>
+          <a:fontRef idx="minor">
+            <a:schemeClr val="lt1"/>
+          </a:fontRef>
+        </p:style>
+        <p:txBody>
+          <a:bodyPr rtlCol="0" anchor="ctr" wrap="square" lIns="127000" rIns="152400" tIns="12700" bIns="12700"/>
+          <a:lstStyle/>
+          <a:p>
+            <a:pPr algn="ctr"/>
+            <a:r>
+              <a:rPr sz="1050" b="1">
+                <a:solidFill>
+                  <a:srgbClr val="FFFFFF"/>
+                </a:solidFill>
+                <a:latin typeface="Calibri"/>
+              </a:rPr>
+              <a:t>Comision. 88 d</a:t>
+            </a:r>
+          </a:p>
+          <a:p>
+            <a:pPr algn="ctr"/>
+            <a:r>
+              <a:rPr sz="850" b="0">
+                <a:solidFill>
+                  <a:srgbClr val="FFFFFF"/>
+                </a:solidFill>
+                <a:latin typeface="Calibri"/>
+              </a:rPr>
+              <a:t>→19-DIC</a:t>
+            </a:r>
+          </a:p>
+        </p:txBody>
+      </p:sp>
+      <p:sp>
+        <p:nvSpPr>
+          <p:cNvPr id="16" name="Rounded Rectangle 15"/>
+          <p:cNvSpPr/>
+          <p:nvPr/>
+        </p:nvSpPr>
+        <p:spPr>
+          <a:xfrm>
+            <a:off x="9921240" y="2057400"/>
+            <a:ext cx="1874519" cy="914400"/>
+          </a:xfrm>
+          <a:prstGeom prst="roundRect">
+            <a:avLst/>
+          </a:prstGeom>
+          <a:solidFill>
+            <a:srgbClr val="C00000"/>
+          </a:solidFill>
+          <a:ln>
+            <a:noFill/>
+          </a:ln>
+          <a:effectLst/>
+        </p:spPr>
+        <p:style>
+          <a:lnRef idx="1">
+            <a:schemeClr val="accent1"/>
+          </a:lnRef>
+          <a:fillRef idx="3">
+            <a:schemeClr val="accent1"/>
+          </a:fillRef>
+          <a:effectRef idx="2">
+            <a:schemeClr val="accent1"/>
+          </a:effectRef>
+          <a:fontRef idx="minor">
+            <a:schemeClr val="lt1"/>
+          </a:fontRef>
+        </p:style>
+        <p:txBody>
+          <a:bodyPr rtlCol="0" anchor="ctr"/>
+          <a:lstStyle/>
+          <a:p>
+            <a:pPr algn="ctr"/>
+            <a:r>
+              <a:rPr sz="1300" b="1">
+                <a:solidFill>
+                  <a:srgbClr val="FFFFFF"/>
+                </a:solidFill>
+                <a:latin typeface="Calibri"/>
+              </a:rPr>
+              <a:t>★ RFSU
+20-DIC-27</a:t>
+            </a:r>
+          </a:p>
+        </p:txBody>
+      </p:sp>
+      <p:sp>
+        <p:nvSpPr>
+          <p:cNvPr id="17" name="TextBox 16"/>
+          <p:cNvSpPr txBox="1"/>
+          <p:nvPr/>
+        </p:nvSpPr>
+        <p:spPr>
+          <a:xfrm>
+            <a:off x="411480" y="3611880"/>
+            <a:ext cx="10058400" cy="274320"/>
+          </a:xfrm>
+          <a:prstGeom prst="rect">
+            <a:avLst/>
+          </a:prstGeom>
+          <a:noFill/>
+        </p:spPr>
+        <p:txBody>
+          <a:bodyPr wrap="square" anchor="t" lIns="25400" rIns="25400">
+            <a:spAutoFit/>
+          </a:bodyPr>
+          <a:lstStyle/>
+          <a:p>
+            <a:pPr algn="l"/>
+            <a:r>
+              <a:rPr sz="1150" b="1">
+                <a:solidFill>
+                  <a:srgbClr val="2E75B6"/>
+                </a:solidFill>
+                <a:latin typeface="Calibri"/>
+              </a:rPr>
+              <a:t>INSTRUMENTACIÓN  ·  debe converger (loop check listo) al comisionado</a:t>
+            </a:r>
+          </a:p>
+        </p:txBody>
+      </p:sp>
+      <p:sp>
+        <p:nvSpPr>
+          <p:cNvPr id="18" name="Chevron 17"/>
+          <p:cNvSpPr/>
+          <p:nvPr/>
+        </p:nvSpPr>
+        <p:spPr>
+          <a:xfrm>
+            <a:off x="411480" y="3931920"/>
+            <a:ext cx="2057400" cy="914400"/>
+          </a:xfrm>
+          <a:prstGeom prst="chevron">
+            <a:avLst/>
+          </a:prstGeom>
+          <a:solidFill>
+            <a:srgbClr val="2E75B6"/>
+          </a:solidFill>
+          <a:ln>
+            <a:noFill/>
+          </a:ln>
+          <a:effectLst/>
+        </p:spPr>
+        <p:style>
+          <a:lnRef idx="1">
+            <a:schemeClr val="accent1"/>
+          </a:lnRef>
+          <a:fillRef idx="3">
+            <a:schemeClr val="accent1"/>
+          </a:fillRef>
+          <a:effectRef idx="2">
+            <a:schemeClr val="accent1"/>
+          </a:effectRef>
+          <a:fontRef idx="minor">
+            <a:schemeClr val="lt1"/>
+          </a:fontRef>
+        </p:style>
+        <p:txBody>
+          <a:bodyPr rtlCol="0" anchor="ctr" wrap="square" lIns="127000" rIns="152400" tIns="12700" bIns="12700"/>
+          <a:lstStyle/>
+          <a:p>
+            <a:pPr algn="ctr"/>
+            <a:r>
+              <a:rPr sz="1050" b="1">
+                <a:solidFill>
+                  <a:srgbClr val="FFFFFF"/>
+                </a:solidFill>
+                <a:latin typeface="Calibri"/>
+              </a:rPr>
+              <a:t>Cables IN tend.</a:t>
+            </a:r>
+          </a:p>
+          <a:p>
+            <a:pPr algn="ctr"/>
+            <a:r>
+              <a:rPr sz="850" b="0">
+                <a:solidFill>
+                  <a:srgbClr val="FFFFFF"/>
+                </a:solidFill>
+                <a:latin typeface="Calibri"/>
+              </a:rPr>
+              <a:t>→14-MAR</a:t>
+            </a:r>
+          </a:p>
+        </p:txBody>
+      </p:sp>
+      <p:sp>
+        <p:nvSpPr>
+          <p:cNvPr id="19" name="Chevron 18"/>
+          <p:cNvSpPr/>
+          <p:nvPr/>
+        </p:nvSpPr>
+        <p:spPr>
+          <a:xfrm>
+            <a:off x="2221992" y="3931920"/>
+            <a:ext cx="2057400" cy="914400"/>
+          </a:xfrm>
+          <a:prstGeom prst="chevron">
+            <a:avLst/>
+          </a:prstGeom>
+          <a:solidFill>
+            <a:srgbClr val="2E75B6"/>
+          </a:solidFill>
+          <a:ln>
+            <a:noFill/>
+          </a:ln>
+          <a:effectLst/>
+        </p:spPr>
+        <p:style>
+          <a:lnRef idx="1">
+            <a:schemeClr val="accent1"/>
+          </a:lnRef>
+          <a:fillRef idx="3">
+            <a:schemeClr val="accent1"/>
+          </a:fillRef>
+          <a:effectRef idx="2">
+            <a:schemeClr val="accent1"/>
+          </a:effectRef>
+          <a:fontRef idx="minor">
+            <a:schemeClr val="lt1"/>
+          </a:fontRef>
+        </p:style>
+        <p:txBody>
+          <a:bodyPr rtlCol="0" anchor="ctr" wrap="square" lIns="127000" rIns="152400" tIns="12700" bIns="12700"/>
+          <a:lstStyle/>
+          <a:p>
+            <a:pPr algn="ctr"/>
+            <a:r>
+              <a:rPr sz="1050" b="1">
+                <a:solidFill>
+                  <a:srgbClr val="FFFFFF"/>
+                </a:solidFill>
+                <a:latin typeface="Calibri"/>
+              </a:rPr>
+              <a:t>PCS Sala INS</a:t>
+            </a:r>
+          </a:p>
+          <a:p>
+            <a:pPr algn="ctr"/>
+            <a:r>
+              <a:rPr sz="850" b="0">
+                <a:solidFill>
+                  <a:srgbClr val="FFFFFF"/>
+                </a:solidFill>
+                <a:latin typeface="Calibri"/>
+              </a:rPr>
+              <a:t>17-MAR</a:t>
+            </a:r>
+          </a:p>
+        </p:txBody>
+      </p:sp>
+      <p:sp>
+        <p:nvSpPr>
+          <p:cNvPr id="20" name="Chevron 19"/>
+          <p:cNvSpPr/>
+          <p:nvPr/>
+        </p:nvSpPr>
+        <p:spPr>
+          <a:xfrm>
+            <a:off x="4032504" y="3931920"/>
+            <a:ext cx="2057400" cy="914400"/>
+          </a:xfrm>
+          <a:prstGeom prst="chevron">
+            <a:avLst/>
+          </a:prstGeom>
+          <a:solidFill>
+            <a:srgbClr val="2E75B6"/>
+          </a:solidFill>
+          <a:ln>
+            <a:noFill/>
+          </a:ln>
+          <a:effectLst/>
+        </p:spPr>
+        <p:style>
+          <a:lnRef idx="1">
+            <a:schemeClr val="accent1"/>
+          </a:lnRef>
+          <a:fillRef idx="3">
+            <a:schemeClr val="accent1"/>
+          </a:fillRef>
+          <a:effectRef idx="2">
+            <a:schemeClr val="accent1"/>
+          </a:effectRef>
+          <a:fontRef idx="minor">
+            <a:schemeClr val="lt1"/>
+          </a:fontRef>
+        </p:style>
+        <p:txBody>
+          <a:bodyPr rtlCol="0" anchor="ctr" wrap="square" lIns="127000" rIns="152400" tIns="12700" bIns="12700"/>
+          <a:lstStyle/>
+          <a:p>
+            <a:pPr algn="ctr"/>
+            <a:r>
+              <a:rPr sz="1050" b="1">
+                <a:solidFill>
+                  <a:srgbClr val="FFFFFF"/>
+                </a:solidFill>
+                <a:latin typeface="Calibri"/>
+              </a:rPr>
+              <a:t>Conexion. IN</a:t>
+            </a:r>
+          </a:p>
+          <a:p>
+            <a:pPr algn="ctr"/>
+            <a:r>
+              <a:rPr sz="850" b="0">
+                <a:solidFill>
+                  <a:srgbClr val="FFFFFF"/>
+                </a:solidFill>
+                <a:latin typeface="Calibri"/>
+              </a:rPr>
+              <a:t>→31-JUL</a:t>
+            </a:r>
+          </a:p>
+        </p:txBody>
+      </p:sp>
+      <p:sp>
+        <p:nvSpPr>
+          <p:cNvPr id="21" name="Chevron 20"/>
+          <p:cNvSpPr/>
+          <p:nvPr/>
+        </p:nvSpPr>
+        <p:spPr>
+          <a:xfrm>
+            <a:off x="5843016" y="3931920"/>
+            <a:ext cx="2057400" cy="914400"/>
+          </a:xfrm>
+          <a:prstGeom prst="chevron">
+            <a:avLst/>
+          </a:prstGeom>
+          <a:solidFill>
+            <a:srgbClr val="2E75B6"/>
+          </a:solidFill>
+          <a:ln>
+            <a:noFill/>
+          </a:ln>
+          <a:effectLst/>
+        </p:spPr>
+        <p:style>
+          <a:lnRef idx="1">
+            <a:schemeClr val="accent1"/>
+          </a:lnRef>
+          <a:fillRef idx="3">
+            <a:schemeClr val="accent1"/>
+          </a:fillRef>
+          <a:effectRef idx="2">
+            <a:schemeClr val="accent1"/>
+          </a:effectRef>
+          <a:fontRef idx="minor">
+            <a:schemeClr val="lt1"/>
+          </a:fontRef>
+        </p:style>
+        <p:txBody>
+          <a:bodyPr rtlCol="0" anchor="ctr" wrap="square" lIns="127000" rIns="152400" tIns="12700" bIns="12700"/>
+          <a:lstStyle/>
+          <a:p>
+            <a:pPr algn="ctr"/>
+            <a:r>
+              <a:rPr sz="1050" b="1">
+                <a:solidFill>
+                  <a:srgbClr val="FFFFFF"/>
+                </a:solidFill>
+                <a:latin typeface="Calibri"/>
+              </a:rPr>
+              <a:t>Loop check IN</a:t>
+            </a:r>
+          </a:p>
+          <a:p>
+            <a:pPr algn="ctr"/>
+            <a:r>
+              <a:rPr sz="850" b="0">
+                <a:solidFill>
+                  <a:srgbClr val="FFFFFF"/>
+                </a:solidFill>
+                <a:latin typeface="Calibri"/>
+              </a:rPr>
+              <a:t>→20-AGO</a:t>
+            </a:r>
+          </a:p>
+        </p:txBody>
+      </p:sp>
+      <p:sp>
+        <p:nvSpPr>
+          <p:cNvPr id="22" name="Up Arrow 21"/>
+          <p:cNvSpPr/>
+          <p:nvPr/>
+        </p:nvSpPr>
+        <p:spPr>
+          <a:xfrm>
+            <a:off x="7635240" y="3063240"/>
+            <a:ext cx="502920" cy="868680"/>
+          </a:xfrm>
+          <a:prstGeom prst="upArrow">
+            <a:avLst/>
+          </a:prstGeom>
+          <a:solidFill>
+            <a:srgbClr val="2E75B6"/>
+          </a:solidFill>
+          <a:ln>
+            <a:noFill/>
+          </a:ln>
+          <a:effectLst/>
+        </p:spPr>
+        <p:style>
+          <a:lnRef idx="1">
+            <a:schemeClr val="accent1"/>
+          </a:lnRef>
+          <a:fillRef idx="3">
+            <a:schemeClr val="accent1"/>
+          </a:fillRef>
+          <a:effectRef idx="2">
+            <a:schemeClr val="accent1"/>
+          </a:effectRef>
+          <a:fontRef idx="minor">
+            <a:schemeClr val="lt1"/>
+          </a:fontRef>
+        </p:style>
+        <p:txBody>
+          <a:bodyPr rtlCol="0" anchor="ctr"/>
+          <a:lstStyle/>
+          <a:p>
+            <a:pPr algn="ctr"/>
+          </a:p>
+        </p:txBody>
+      </p:sp>
+      <p:sp>
+        <p:nvSpPr>
+          <p:cNvPr id="23" name="TextBox 22"/>
+          <p:cNvSpPr txBox="1"/>
+          <p:nvPr/>
+        </p:nvSpPr>
+        <p:spPr>
+          <a:xfrm>
+            <a:off x="7360920" y="2926080"/>
+            <a:ext cx="1188720" cy="228600"/>
+          </a:xfrm>
+          <a:prstGeom prst="rect">
+            <a:avLst/>
+          </a:prstGeom>
+          <a:noFill/>
+        </p:spPr>
+        <p:txBody>
+          <a:bodyPr wrap="square" anchor="t" lIns="25400" rIns="25400">
+            <a:spAutoFit/>
+          </a:bodyPr>
+          <a:lstStyle/>
+          <a:p>
+            <a:pPr algn="ctr"/>
+            <a:r>
+              <a:rPr sz="900" b="1">
+                <a:solidFill>
+                  <a:srgbClr val="2E75B6"/>
+                </a:solidFill>
+                <a:latin typeface="Calibri"/>
+              </a:rPr>
+              <a:t>converge</a:t>
+            </a:r>
+          </a:p>
+        </p:txBody>
+      </p:sp>
+      <p:sp>
+        <p:nvSpPr>
+          <p:cNvPr id="24" name="Rectangle 23"/>
+          <p:cNvSpPr/>
+          <p:nvPr/>
+        </p:nvSpPr>
+        <p:spPr>
+          <a:xfrm>
+            <a:off x="411480" y="5166360"/>
+            <a:ext cx="11384280" cy="1143000"/>
+          </a:xfrm>
+          <a:prstGeom prst="rect">
+            <a:avLst/>
+          </a:prstGeom>
+          <a:solidFill>
+            <a:srgbClr val="F2F2F2"/>
+          </a:solidFill>
+          <a:ln>
+            <a:noFill/>
+          </a:ln>
+          <a:effectLst/>
+        </p:spPr>
+        <p:style>
+          <a:lnRef idx="1">
+            <a:schemeClr val="accent1"/>
+          </a:lnRef>
+          <a:fillRef idx="3">
+            <a:schemeClr val="accent1"/>
+          </a:fillRef>
+          <a:effectRef idx="2">
+            <a:schemeClr val="accent1"/>
+          </a:effectRef>
+          <a:fontRef idx="minor">
+            <a:schemeClr val="lt1"/>
+          </a:fontRef>
+        </p:style>
+        <p:txBody>
+          <a:bodyPr rtlCol="0" anchor="ctr"/>
+          <a:lstStyle/>
+          <a:p>
+            <a:pPr algn="ctr"/>
+          </a:p>
+        </p:txBody>
+      </p:sp>
+      <p:sp>
+        <p:nvSpPr>
+          <p:cNvPr id="25" name="TextBox 24"/>
+          <p:cNvSpPr txBox="1"/>
+          <p:nvPr/>
+        </p:nvSpPr>
+        <p:spPr>
+          <a:xfrm>
+            <a:off x="548640" y="5230368"/>
+            <a:ext cx="11155680" cy="1097280"/>
+          </a:xfrm>
+          <a:prstGeom prst="rect">
+            <a:avLst/>
+          </a:prstGeom>
+          <a:noFill/>
+        </p:spPr>
+        <p:txBody>
+          <a:bodyPr wrap="square">
+            <a:spAutoFit/>
+          </a:bodyPr>
+          <a:lstStyle/>
+          <a:p>
+            <a:pPr>
+              <a:spcAft>
+                <a:spcPts val="400"/>
+              </a:spcAft>
+            </a:pPr>
+            <a:r>
+              <a:rPr sz="1150" b="1">
+                <a:solidFill>
+                  <a:srgbClr val="C00000"/>
+                </a:solidFill>
+                <a:latin typeface="Calibri"/>
+              </a:rPr>
+              <a:t>• Cadena crítica: SE#3 14-MAY → armado 21 d → conexionado EL 51 d → megger 21 d → energización 17 d → precom 21 d → comisionado 88 d ≈ 19-DIC (margen mínimo a RFSU 20-DIC).</a:t>
+            </a:r>
+          </a:p>
+          <a:p>
+            <a:pPr>
+              <a:spcAft>
+                <a:spcPts val="400"/>
+              </a:spcAft>
+            </a:pPr>
+            <a:r>
+              <a:rPr sz="1150" b="1">
+                <a:solidFill>
+                  <a:srgbClr val="1F3B63"/>
+                </a:solidFill>
+                <a:latin typeface="Calibri"/>
+              </a:rPr>
+              <a:t>• Gatillos que la sostienen: OC Cables IN ≤01-AGO-26 · OC Cables EL ≤01-OCT-26 · ⛔ cables IN tendidos antes 17-MAR (PCS) · ⛔ cables EL tendidos antes 14-MAY (SE#3).</a:t>
+            </a:r>
+          </a:p>
+          <a:p>
+            <a:pPr>
+              <a:spcAft>
+                <a:spcPts val="400"/>
+              </a:spcAft>
+            </a:pPr>
+            <a:r>
+              <a:rPr sz="1150" b="1">
+                <a:solidFill>
+                  <a:srgbClr val="2E75B6"/>
+                </a:solidFill>
+                <a:latin typeface="Calibri"/>
+              </a:rPr>
+              <a:t>• IN no está en la ruta crítica del frente EL, pero su loop check debe estar listo para no frenar el comisionado integrado.</a:t>
+            </a:r>
+          </a:p>
+        </p:txBody>
+      </p:sp>
+      <p:sp>
+        <p:nvSpPr>
+          <p:cNvPr id="26" name="TextBox 25"/>
+          <p:cNvSpPr txBox="1"/>
+          <p:nvPr/>
+        </p:nvSpPr>
+        <p:spPr>
+          <a:xfrm>
+            <a:off x="411480" y="6473952"/>
+            <a:ext cx="8229600" cy="274320"/>
+          </a:xfrm>
+          <a:prstGeom prst="rect">
+            <a:avLst/>
+          </a:prstGeom>
+          <a:noFill/>
+        </p:spPr>
+        <p:txBody>
+          <a:bodyPr wrap="square" anchor="t" lIns="25400" rIns="25400">
+            <a:spAutoFit/>
+          </a:bodyPr>
+          <a:lstStyle/>
+          <a:p>
+            <a:pPr algn="l"/>
+            <a:r>
+              <a:rPr sz="900" b="0">
+                <a:solidFill>
+                  <a:srgbClr val="595959"/>
+                </a:solidFill>
+                <a:latin typeface="Calibri"/>
+              </a:rPr>
+              <a:t>Constructibilidad CPF2 · Alcance por especialidad · Rev. 0 · 13-06-2026</a:t>
+            </a:r>
+          </a:p>
+        </p:txBody>
+      </p:sp>
+      <p:sp>
+        <p:nvSpPr>
+          <p:cNvPr id="27" name="TextBox 26"/>
+          <p:cNvSpPr txBox="1"/>
+          <p:nvPr/>
+        </p:nvSpPr>
+        <p:spPr>
+          <a:xfrm>
+            <a:off x="11155680" y="6473952"/>
+            <a:ext cx="822960" cy="274320"/>
+          </a:xfrm>
+          <a:prstGeom prst="rect">
+            <a:avLst/>
+          </a:prstGeom>
+          <a:noFill/>
+        </p:spPr>
+        <p:txBody>
+          <a:bodyPr wrap="square" anchor="t" lIns="25400" rIns="25400">
+            <a:spAutoFit/>
+          </a:bodyPr>
+          <a:lstStyle/>
+          <a:p>
+            <a:pPr algn="r"/>
+            <a:r>
+              <a:rPr sz="900" b="0">
+                <a:solidFill>
+                  <a:srgbClr val="595959"/>
+                </a:solidFill>
+                <a:latin typeface="Calibri"/>
+              </a:rPr>
+              <a:t>18</a:t>
             </a:r>
           </a:p>
         </p:txBody>

</xml_diff>